<commit_message>
/add documetation fichier Data + update Jalon2
</commit_message>
<xml_diff>
--- a/Jalon 2.pptx
+++ b/Jalon 2.pptx
@@ -8,6 +8,10 @@
     <p:sldId id="256" r:id="rId5"/>
     <p:sldId id="257" r:id="rId6"/>
     <p:sldId id="258" r:id="rId7"/>
+    <p:sldId id="259" r:id="rId8"/>
+    <p:sldId id="260" r:id="rId9"/>
+    <p:sldId id="261" r:id="rId10"/>
+    <p:sldId id="262" r:id="rId11"/>
   </p:sldIdLst>
   <p:sldSz cx="12192000" cy="6858000"/>
   <p:notesSz cx="6858000" cy="9144000"/>
@@ -106,6 +110,11 @@
       </a:defRPr>
     </a:lvl9pPr>
   </p:defaultTextStyle>
+  <p:extLst>
+    <p:ext uri="{EFAFB233-063F-42B5-8137-9DF3F51BA10A}">
+      <p15:sldGuideLst xmlns:p15="http://schemas.microsoft.com/office/powerpoint/2012/main"/>
+    </p:ext>
+  </p:extLst>
 </p:presentation>
 </file>
 
@@ -3372,7 +3381,18 @@
           <a:bodyPr/>
           <a:lstStyle/>
           <a:p>
-            <a:endParaRPr lang="fr-FR"/>
+            <a:r>
+              <a:rPr lang="fr-FR" dirty="0"/>
+              <a:t>Delin Mattéo, Sharon Guedj, Antoine </a:t>
+            </a:r>
+            <a:r>
+              <a:rPr lang="fr-FR" dirty="0" err="1"/>
+              <a:t>Maurin</a:t>
+            </a:r>
+            <a:r>
+              <a:rPr lang="fr-FR" dirty="0"/>
+              <a:t>, Quentin Zavagno</a:t>
+            </a:r>
           </a:p>
         </p:txBody>
       </p:sp>
@@ -3540,7 +3560,10 @@
           <a:bodyPr/>
           <a:lstStyle/>
           <a:p>
-            <a:endParaRPr lang="fr-FR"/>
+            <a:r>
+              <a:rPr lang="fr-FR" dirty="0"/>
+              <a:t>Enjeux métiers</a:t>
+            </a:r>
           </a:p>
         </p:txBody>
       </p:sp>
@@ -3565,7 +3588,28 @@
           <a:bodyPr/>
           <a:lstStyle/>
           <a:p>
-            <a:endParaRPr lang="fr-FR"/>
+            <a:r>
+              <a:rPr lang="fr-FR" dirty="0"/>
+              <a:t>Identifier les zones géographiques présentant un indice de saturation élevé.</a:t>
+            </a:r>
+          </a:p>
+          <a:p>
+            <a:r>
+              <a:rPr lang="fr-FR" dirty="0"/>
+              <a:t>Déterminer les zones de tension où l'offre est insuffisante face à la demande croissante.</a:t>
+            </a:r>
+          </a:p>
+          <a:p>
+            <a:r>
+              <a:rPr lang="fr-FR" dirty="0"/>
+              <a:t>Analyser le positionnement stratégique et la part de marché des principaux groupes privés nationaux.</a:t>
+            </a:r>
+          </a:p>
+          <a:p>
+            <a:r>
+              <a:rPr lang="fr-FR" dirty="0"/>
+              <a:t>Déterminer le modèle d'établissement le plus adapté (Privé, Public ou Associatif) en fonction du profil de richesse et du pouvoir d'achat des retraités de la zone géographique.</a:t>
+            </a:r>
           </a:p>
         </p:txBody>
       </p:sp>
@@ -3573,6 +3617,338 @@
     <p:extLst>
       <p:ext uri="{BB962C8B-B14F-4D97-AF65-F5344CB8AC3E}">
         <p14:creationId xmlns:p14="http://schemas.microsoft.com/office/powerpoint/2010/main" val="1261267513"/>
+      </p:ext>
+    </p:extLst>
+  </p:cSld>
+  <p:clrMapOvr>
+    <a:masterClrMapping/>
+  </p:clrMapOvr>
+</p:sld>
+</file>
+
+<file path=ppt/slides/slide4.xml><?xml version="1.0" encoding="utf-8"?>
+<p:sld xmlns:a="http://schemas.openxmlformats.org/drawingml/2006/main" xmlns:r="http://schemas.openxmlformats.org/officeDocument/2006/relationships" xmlns:p="http://schemas.openxmlformats.org/presentationml/2006/main">
+  <p:cSld>
+    <p:spTree>
+      <p:nvGrpSpPr>
+        <p:cNvPr id="1" name=""/>
+        <p:cNvGrpSpPr/>
+        <p:nvPr/>
+      </p:nvGrpSpPr>
+      <p:grpSpPr>
+        <a:xfrm>
+          <a:off x="0" y="0"/>
+          <a:ext cx="0" cy="0"/>
+          <a:chOff x="0" y="0"/>
+          <a:chExt cx="0" cy="0"/>
+        </a:xfrm>
+      </p:grpSpPr>
+      <p:sp>
+        <p:nvSpPr>
+          <p:cNvPr id="2" name="Titre 1">
+            <a:extLst>
+              <a:ext uri="{FF2B5EF4-FFF2-40B4-BE49-F238E27FC236}">
+                <a16:creationId xmlns:a16="http://schemas.microsoft.com/office/drawing/2014/main" id="{2B31BF0E-346C-405A-31EA-0E8A57A2F293}"/>
+              </a:ext>
+            </a:extLst>
+          </p:cNvPr>
+          <p:cNvSpPr>
+            <a:spLocks noGrp="1"/>
+          </p:cNvSpPr>
+          <p:nvPr>
+            <p:ph type="title"/>
+          </p:nvPr>
+        </p:nvSpPr>
+        <p:spPr/>
+        <p:txBody>
+          <a:bodyPr/>
+          <a:lstStyle/>
+          <a:p>
+            <a:r>
+              <a:rPr lang="fr-FR" dirty="0"/>
+              <a:t>Difficultés et solution</a:t>
+            </a:r>
+          </a:p>
+        </p:txBody>
+      </p:sp>
+      <p:sp>
+        <p:nvSpPr>
+          <p:cNvPr id="3" name="Espace réservé du contenu 2">
+            <a:extLst>
+              <a:ext uri="{FF2B5EF4-FFF2-40B4-BE49-F238E27FC236}">
+                <a16:creationId xmlns:a16="http://schemas.microsoft.com/office/drawing/2014/main" id="{04459774-AA9E-BA7C-F2B2-72654B3A6906}"/>
+              </a:ext>
+            </a:extLst>
+          </p:cNvPr>
+          <p:cNvSpPr>
+            <a:spLocks noGrp="1"/>
+          </p:cNvSpPr>
+          <p:nvPr>
+            <p:ph idx="1"/>
+          </p:nvPr>
+        </p:nvSpPr>
+        <p:spPr/>
+        <p:txBody>
+          <a:bodyPr/>
+          <a:lstStyle/>
+          <a:p>
+            <a:endParaRPr lang="fr-FR"/>
+          </a:p>
+        </p:txBody>
+      </p:sp>
+    </p:spTree>
+    <p:extLst>
+      <p:ext uri="{BB962C8B-B14F-4D97-AF65-F5344CB8AC3E}">
+        <p14:creationId xmlns:p14="http://schemas.microsoft.com/office/powerpoint/2010/main" val="3084630590"/>
+      </p:ext>
+    </p:extLst>
+  </p:cSld>
+  <p:clrMapOvr>
+    <a:masterClrMapping/>
+  </p:clrMapOvr>
+</p:sld>
+</file>
+
+<file path=ppt/slides/slide5.xml><?xml version="1.0" encoding="utf-8"?>
+<p:sld xmlns:a="http://schemas.openxmlformats.org/drawingml/2006/main" xmlns:r="http://schemas.openxmlformats.org/officeDocument/2006/relationships" xmlns:p="http://schemas.openxmlformats.org/presentationml/2006/main">
+  <p:cSld>
+    <p:spTree>
+      <p:nvGrpSpPr>
+        <p:cNvPr id="1" name=""/>
+        <p:cNvGrpSpPr/>
+        <p:nvPr/>
+      </p:nvGrpSpPr>
+      <p:grpSpPr>
+        <a:xfrm>
+          <a:off x="0" y="0"/>
+          <a:ext cx="0" cy="0"/>
+          <a:chOff x="0" y="0"/>
+          <a:chExt cx="0" cy="0"/>
+        </a:xfrm>
+      </p:grpSpPr>
+      <p:sp>
+        <p:nvSpPr>
+          <p:cNvPr id="2" name="Titre 1">
+            <a:extLst>
+              <a:ext uri="{FF2B5EF4-FFF2-40B4-BE49-F238E27FC236}">
+                <a16:creationId xmlns:a16="http://schemas.microsoft.com/office/drawing/2014/main" id="{9DDB9C2D-7570-F14A-7EDA-B72EADFC5051}"/>
+              </a:ext>
+            </a:extLst>
+          </p:cNvPr>
+          <p:cNvSpPr>
+            <a:spLocks noGrp="1"/>
+          </p:cNvSpPr>
+          <p:nvPr>
+            <p:ph type="title"/>
+          </p:nvPr>
+        </p:nvSpPr>
+        <p:spPr/>
+        <p:txBody>
+          <a:bodyPr/>
+          <a:lstStyle/>
+          <a:p>
+            <a:r>
+              <a:rPr lang="fr-FR" dirty="0"/>
+              <a:t>Fonctionnalité de l’application</a:t>
+            </a:r>
+          </a:p>
+        </p:txBody>
+      </p:sp>
+      <p:sp>
+        <p:nvSpPr>
+          <p:cNvPr id="3" name="Espace réservé du contenu 2">
+            <a:extLst>
+              <a:ext uri="{FF2B5EF4-FFF2-40B4-BE49-F238E27FC236}">
+                <a16:creationId xmlns:a16="http://schemas.microsoft.com/office/drawing/2014/main" id="{A18F854A-DBC3-2BED-1B62-578805EBD554}"/>
+              </a:ext>
+            </a:extLst>
+          </p:cNvPr>
+          <p:cNvSpPr>
+            <a:spLocks noGrp="1"/>
+          </p:cNvSpPr>
+          <p:nvPr>
+            <p:ph idx="1"/>
+          </p:nvPr>
+        </p:nvSpPr>
+        <p:spPr/>
+        <p:txBody>
+          <a:bodyPr/>
+          <a:lstStyle/>
+          <a:p>
+            <a:endParaRPr lang="fr-FR"/>
+          </a:p>
+        </p:txBody>
+      </p:sp>
+    </p:spTree>
+    <p:extLst>
+      <p:ext uri="{BB962C8B-B14F-4D97-AF65-F5344CB8AC3E}">
+        <p14:creationId xmlns:p14="http://schemas.microsoft.com/office/powerpoint/2010/main" val="2330101234"/>
+      </p:ext>
+    </p:extLst>
+  </p:cSld>
+  <p:clrMapOvr>
+    <a:masterClrMapping/>
+  </p:clrMapOvr>
+</p:sld>
+</file>
+
+<file path=ppt/slides/slide6.xml><?xml version="1.0" encoding="utf-8"?>
+<p:sld xmlns:a="http://schemas.openxmlformats.org/drawingml/2006/main" xmlns:r="http://schemas.openxmlformats.org/officeDocument/2006/relationships" xmlns:p="http://schemas.openxmlformats.org/presentationml/2006/main">
+  <p:cSld>
+    <p:spTree>
+      <p:nvGrpSpPr>
+        <p:cNvPr id="1" name=""/>
+        <p:cNvGrpSpPr/>
+        <p:nvPr/>
+      </p:nvGrpSpPr>
+      <p:grpSpPr>
+        <a:xfrm>
+          <a:off x="0" y="0"/>
+          <a:ext cx="0" cy="0"/>
+          <a:chOff x="0" y="0"/>
+          <a:chExt cx="0" cy="0"/>
+        </a:xfrm>
+      </p:grpSpPr>
+      <p:sp>
+        <p:nvSpPr>
+          <p:cNvPr id="2" name="Titre 1">
+            <a:extLst>
+              <a:ext uri="{FF2B5EF4-FFF2-40B4-BE49-F238E27FC236}">
+                <a16:creationId xmlns:a16="http://schemas.microsoft.com/office/drawing/2014/main" id="{DC31ED0B-1722-AFDF-0FC6-3FC5033E23A7}"/>
+              </a:ext>
+            </a:extLst>
+          </p:cNvPr>
+          <p:cNvSpPr>
+            <a:spLocks noGrp="1"/>
+          </p:cNvSpPr>
+          <p:nvPr>
+            <p:ph type="title"/>
+          </p:nvPr>
+        </p:nvSpPr>
+        <p:spPr/>
+        <p:txBody>
+          <a:bodyPr/>
+          <a:lstStyle/>
+          <a:p>
+            <a:r>
+              <a:rPr lang="fr-FR" dirty="0"/>
+              <a:t>Compléments</a:t>
+            </a:r>
+          </a:p>
+        </p:txBody>
+      </p:sp>
+      <p:sp>
+        <p:nvSpPr>
+          <p:cNvPr id="3" name="Espace réservé du contenu 2">
+            <a:extLst>
+              <a:ext uri="{FF2B5EF4-FFF2-40B4-BE49-F238E27FC236}">
+                <a16:creationId xmlns:a16="http://schemas.microsoft.com/office/drawing/2014/main" id="{1A60AB0D-9F26-184A-90EE-391D7F380C08}"/>
+              </a:ext>
+            </a:extLst>
+          </p:cNvPr>
+          <p:cNvSpPr>
+            <a:spLocks noGrp="1"/>
+          </p:cNvSpPr>
+          <p:nvPr>
+            <p:ph idx="1"/>
+          </p:nvPr>
+        </p:nvSpPr>
+        <p:spPr/>
+        <p:txBody>
+          <a:bodyPr/>
+          <a:lstStyle/>
+          <a:p>
+            <a:endParaRPr lang="fr-FR"/>
+          </a:p>
+        </p:txBody>
+      </p:sp>
+    </p:spTree>
+    <p:extLst>
+      <p:ext uri="{BB962C8B-B14F-4D97-AF65-F5344CB8AC3E}">
+        <p14:creationId xmlns:p14="http://schemas.microsoft.com/office/powerpoint/2010/main" val="3961200671"/>
+      </p:ext>
+    </p:extLst>
+  </p:cSld>
+  <p:clrMapOvr>
+    <a:masterClrMapping/>
+  </p:clrMapOvr>
+</p:sld>
+</file>
+
+<file path=ppt/slides/slide7.xml><?xml version="1.0" encoding="utf-8"?>
+<p:sld xmlns:a="http://schemas.openxmlformats.org/drawingml/2006/main" xmlns:r="http://schemas.openxmlformats.org/officeDocument/2006/relationships" xmlns:p="http://schemas.openxmlformats.org/presentationml/2006/main">
+  <p:cSld>
+    <p:spTree>
+      <p:nvGrpSpPr>
+        <p:cNvPr id="1" name=""/>
+        <p:cNvGrpSpPr/>
+        <p:nvPr/>
+      </p:nvGrpSpPr>
+      <p:grpSpPr>
+        <a:xfrm>
+          <a:off x="0" y="0"/>
+          <a:ext cx="0" cy="0"/>
+          <a:chOff x="0" y="0"/>
+          <a:chExt cx="0" cy="0"/>
+        </a:xfrm>
+      </p:grpSpPr>
+      <p:sp>
+        <p:nvSpPr>
+          <p:cNvPr id="2" name="Titre 1">
+            <a:extLst>
+              <a:ext uri="{FF2B5EF4-FFF2-40B4-BE49-F238E27FC236}">
+                <a16:creationId xmlns:a16="http://schemas.microsoft.com/office/drawing/2014/main" id="{EC8C4E6C-D055-954C-3EA3-828DE2FB0249}"/>
+              </a:ext>
+            </a:extLst>
+          </p:cNvPr>
+          <p:cNvSpPr>
+            <a:spLocks noGrp="1"/>
+          </p:cNvSpPr>
+          <p:nvPr>
+            <p:ph type="title"/>
+          </p:nvPr>
+        </p:nvSpPr>
+        <p:spPr/>
+        <p:txBody>
+          <a:bodyPr/>
+          <a:lstStyle/>
+          <a:p>
+            <a:r>
+              <a:rPr lang="fr-FR" dirty="0"/>
+              <a:t>Exemples de données-situations particulières</a:t>
+            </a:r>
+          </a:p>
+        </p:txBody>
+      </p:sp>
+      <p:sp>
+        <p:nvSpPr>
+          <p:cNvPr id="3" name="Espace réservé du contenu 2">
+            <a:extLst>
+              <a:ext uri="{FF2B5EF4-FFF2-40B4-BE49-F238E27FC236}">
+                <a16:creationId xmlns:a16="http://schemas.microsoft.com/office/drawing/2014/main" id="{622DF5CE-5943-8EAD-68B7-F25F684FE0DD}"/>
+              </a:ext>
+            </a:extLst>
+          </p:cNvPr>
+          <p:cNvSpPr>
+            <a:spLocks noGrp="1"/>
+          </p:cNvSpPr>
+          <p:nvPr>
+            <p:ph idx="1"/>
+          </p:nvPr>
+        </p:nvSpPr>
+        <p:spPr/>
+        <p:txBody>
+          <a:bodyPr/>
+          <a:lstStyle/>
+          <a:p>
+            <a:endParaRPr lang="fr-FR"/>
+          </a:p>
+        </p:txBody>
+      </p:sp>
+    </p:spTree>
+    <p:extLst>
+      <p:ext uri="{BB962C8B-B14F-4D97-AF65-F5344CB8AC3E}">
+        <p14:creationId xmlns:p14="http://schemas.microsoft.com/office/powerpoint/2010/main" val="787401801"/>
       </p:ext>
     </p:extLst>
   </p:cSld>
@@ -3898,6 +4274,21 @@
 </file>
 
 <file path=customXml/item1.xml><?xml version="1.0" encoding="utf-8"?>
+<p:properties xmlns:p="http://schemas.microsoft.com/office/2006/metadata/properties" xmlns:xsi="http://www.w3.org/2001/XMLSchema-instance" xmlns:pc="http://schemas.microsoft.com/office/infopath/2007/PartnerControls">
+  <documentManagement/>
+</p:properties>
+</file>
+
+<file path=customXml/item2.xml><?xml version="1.0" encoding="utf-8"?>
+<?mso-contentType ?>
+<FormTemplates xmlns="http://schemas.microsoft.com/sharepoint/v3/contenttype/forms">
+  <Display>DocumentLibraryForm</Display>
+  <Edit>DocumentLibraryForm</Edit>
+  <New>DocumentLibraryForm</New>
+</FormTemplates>
+</file>
+
+<file path=customXml/item3.xml><?xml version="1.0" encoding="utf-8"?>
 <ct:contentTypeSchema xmlns:ct="http://schemas.microsoft.com/office/2006/metadata/contentType" xmlns:ma="http://schemas.microsoft.com/office/2006/metadata/properties/metaAttributes" ct:_="" ma:_="" ma:contentTypeName="Document" ma:contentTypeID="0x0101002C2FA9CFC59BEE4C808E8A7EC7786DF4" ma:contentTypeVersion="5" ma:contentTypeDescription="Crée un document." ma:contentTypeScope="" ma:versionID="51f100069d6b0785e43647d7ccf26c68">
   <xsd:schema xmlns:xsd="http://www.w3.org/2001/XMLSchema" xmlns:xs="http://www.w3.org/2001/XMLSchema" xmlns:p="http://schemas.microsoft.com/office/2006/metadata/properties" xmlns:ns3="a52f57f2-e734-4627-95df-5343de9975ec" targetNamespace="http://schemas.microsoft.com/office/2006/metadata/properties" ma:root="true" ma:fieldsID="4ad4403c10857f5787a8f21f372a6c91" ns3:_="">
     <xsd:import namespace="a52f57f2-e734-4627-95df-5343de9975ec"/>
@@ -4047,22 +4438,31 @@
 </ct:contentTypeSchema>
 </file>
 
-<file path=customXml/item2.xml><?xml version="1.0" encoding="utf-8"?>
-<?mso-contentType ?>
-<FormTemplates xmlns="http://schemas.microsoft.com/sharepoint/v3/contenttype/forms">
-  <Display>DocumentLibraryForm</Display>
-  <Edit>DocumentLibraryForm</Edit>
-  <New>DocumentLibraryForm</New>
-</FormTemplates>
+<file path=customXml/itemProps1.xml><?xml version="1.0" encoding="utf-8"?>
+<ds:datastoreItem xmlns:ds="http://schemas.openxmlformats.org/officeDocument/2006/customXml" ds:itemID="{DA2A77FD-E83A-49F3-AA24-2DF68F24FFFF}">
+  <ds:schemaRefs>
+    <ds:schemaRef ds:uri="http://schemas.microsoft.com/office/2006/documentManagement/types"/>
+    <ds:schemaRef ds:uri="http://purl.org/dc/elements/1.1/"/>
+    <ds:schemaRef ds:uri="http://schemas.microsoft.com/office/2006/metadata/properties"/>
+    <ds:schemaRef ds:uri="http://schemas.microsoft.com/office/infopath/2007/PartnerControls"/>
+    <ds:schemaRef ds:uri="http://schemas.openxmlformats.org/package/2006/metadata/core-properties"/>
+    <ds:schemaRef ds:uri="a52f57f2-e734-4627-95df-5343de9975ec"/>
+    <ds:schemaRef ds:uri="http://purl.org/dc/terms/"/>
+    <ds:schemaRef ds:uri="http://www.w3.org/XML/1998/namespace"/>
+    <ds:schemaRef ds:uri="http://purl.org/dc/dcmitype/"/>
+  </ds:schemaRefs>
+</ds:datastoreItem>
 </file>
 
-<file path=customXml/item3.xml><?xml version="1.0" encoding="utf-8"?>
-<p:properties xmlns:p="http://schemas.microsoft.com/office/2006/metadata/properties" xmlns:xsi="http://www.w3.org/2001/XMLSchema-instance" xmlns:pc="http://schemas.microsoft.com/office/infopath/2007/PartnerControls">
-  <documentManagement/>
-</p:properties>
+<file path=customXml/itemProps2.xml><?xml version="1.0" encoding="utf-8"?>
+<ds:datastoreItem xmlns:ds="http://schemas.openxmlformats.org/officeDocument/2006/customXml" ds:itemID="{29967508-4AF0-42CC-A361-613486D06D24}">
+  <ds:schemaRefs>
+    <ds:schemaRef ds:uri="http://schemas.microsoft.com/sharepoint/v3/contenttype/forms"/>
+  </ds:schemaRefs>
+</ds:datastoreItem>
 </file>
 
-<file path=customXml/itemProps1.xml><?xml version="1.0" encoding="utf-8"?>
+<file path=customXml/itemProps3.xml><?xml version="1.0" encoding="utf-8"?>
 <ds:datastoreItem xmlns:ds="http://schemas.openxmlformats.org/officeDocument/2006/customXml" ds:itemID="{67980FC5-1080-4C88-B246-460ECD09960C}">
   <ds:schemaRefs>
     <ds:schemaRef ds:uri="http://schemas.microsoft.com/office/2006/metadata/contentType"/>
@@ -4078,28 +4478,4 @@
     <ds:schemaRef ds:uri="http://schemas.microsoft.com/internal/obd"/>
   </ds:schemaRefs>
 </ds:datastoreItem>
-</file>
-
-<file path=customXml/itemProps2.xml><?xml version="1.0" encoding="utf-8"?>
-<ds:datastoreItem xmlns:ds="http://schemas.openxmlformats.org/officeDocument/2006/customXml" ds:itemID="{29967508-4AF0-42CC-A361-613486D06D24}">
-  <ds:schemaRefs>
-    <ds:schemaRef ds:uri="http://schemas.microsoft.com/sharepoint/v3/contenttype/forms"/>
-  </ds:schemaRefs>
-</ds:datastoreItem>
-</file>
-
-<file path=customXml/itemProps3.xml><?xml version="1.0" encoding="utf-8"?>
-<ds:datastoreItem xmlns:ds="http://schemas.openxmlformats.org/officeDocument/2006/customXml" ds:itemID="{DA2A77FD-E83A-49F3-AA24-2DF68F24FFFF}">
-  <ds:schemaRefs>
-    <ds:schemaRef ds:uri="http://schemas.microsoft.com/office/2006/documentManagement/types"/>
-    <ds:schemaRef ds:uri="http://purl.org/dc/elements/1.1/"/>
-    <ds:schemaRef ds:uri="http://schemas.microsoft.com/office/2006/metadata/properties"/>
-    <ds:schemaRef ds:uri="http://schemas.microsoft.com/office/infopath/2007/PartnerControls"/>
-    <ds:schemaRef ds:uri="http://schemas.openxmlformats.org/package/2006/metadata/core-properties"/>
-    <ds:schemaRef ds:uri="a52f57f2-e734-4627-95df-5343de9975ec"/>
-    <ds:schemaRef ds:uri="http://purl.org/dc/terms/"/>
-    <ds:schemaRef ds:uri="http://www.w3.org/XML/1998/namespace"/>
-    <ds:schemaRef ds:uri="http://purl.org/dc/dcmitype/"/>
-  </ds:schemaRefs>
-</ds:datastoreItem>
 </file>
</xml_diff>